<commit_message>
Add code-spotlight slide to demo deck
- New slide 4: toggleFavorite immutable-Set snippet + 'why it matters' panel,
  chosen for defensibility (every follow-up answerable from React basics)
- Reflection moves to slide 5; timing rebalanced to fit 5:00
- PRESENTATION.md: code-slide script + Q&A prep; trailers moved from
  'next steps' to shipped (it's built now)
</commit_message>
<xml_diff>
--- a/presentation/Flixster-Demo.pptx
+++ b/presentation/Flixster-Demo.pptx
@@ -9,6 +9,7 @@
     <p:sldId id="257" r:id="rId9"/>
     <p:sldId id="258" r:id="rId10"/>
     <p:sldId id="259" r:id="rId11"/>
+    <p:sldId id="260" r:id="rId12"/>
   </p:sldIdLst>
   <p:sldSz cx="12191695" cy="6858000" type="screen4x3"/>
   <p:notesSz cx="6858000" cy="9144000"/>
@@ -575,7 +576,7 @@
           <a:lstStyle/>
           <a:p>
             <a:r>
-              <a:t>TIME 2:45 — THE MAIN EVENT. Talk WHILE you click; follow the numbered order. Go slow on the AI insight (4) and sidebar (6) — your standouts. If the AI is rate-limited: 'the free model is busy, so instead of breaking it shows a friendly fallback — I built that on purpose.' Wrap by 3:30.</a:t>
+              <a:t>TIME 2:45 — THE MAIN EVENT. Talk WHILE you click; follow the order. Go slow on the AI insight + trailer (4) and sidebar (6). If the AI is rate-limited: 'the free model is busy, so instead of breaking it shows a friendly fallback — I built that on purpose.' Wrap by 3:30.</a:t>
             </a:r>
           </a:p>
         </p:txBody>
@@ -715,7 +716,77 @@
           <a:lstStyle/>
           <a:p>
             <a:r>
-              <a:t>TIME 0:45. End on Next Steps energy — shows you think like a builder. Favorite = AI insight. Challenging = interacting state / bugs in the seams. Land the last line, eye contact, stop. ~95 words. 'Thanks — happy to take questions!'</a:t>
+              <a:t>TIME 0:40. The defensible depth slide. SAY: 'Favorites is the piece of state everything else touches. If I'd mutated it with prev.add(id), React compares by reference, sees the same Set, and skips the re-render — UI goes stale. So I build a NEW Set, toggle the id, return it: new identity, guaranteed re-render. And the prev =&gt; … form always reads the latest state.' LIKELY Qs: (1) why new Set not prev.add? → reference compare / Object.is. (2) why functional updater? → avoids stale closure on rapid toggles. (3) why Set not array? → O(1) has/add/delete, no duplicates.</a:t>
+            </a:r>
+          </a:p>
+        </p:txBody>
+      </p:sp>
+      <p:sp>
+        <p:nvSpPr>
+          <p:cNvPr id="4" name="Slide Number Placeholder 3"/>
+          <p:cNvSpPr>
+            <a:spLocks noGrp="1"/>
+          </p:cNvSpPr>
+          <p:nvPr>
+            <p:ph type="sldNum" idx="5" sz="quarter"/>
+          </p:nvPr>
+        </p:nvSpPr>
+        <p:spPr/>
+      </p:sp>
+    </p:spTree>
+  </p:cSld>
+  <p:clrMapOvr>
+    <a:masterClrMapping/>
+  </p:clrMapOvr>
+</p:notes>
+</file>
+
+<file path=ppt/notesSlides/notesSlide5.xml><?xml version="1.0" encoding="utf-8"?>
+<p:notes xmlns:a="http://schemas.openxmlformats.org/drawingml/2006/main" xmlns:p="http://schemas.openxmlformats.org/presentationml/2006/main" xmlns:r="http://schemas.openxmlformats.org/officeDocument/2006/relationships">
+  <p:cSld>
+    <p:spTree>
+      <p:nvGrpSpPr>
+        <p:cNvPr id="1" name=""/>
+        <p:cNvGrpSpPr/>
+        <p:nvPr/>
+      </p:nvGrpSpPr>
+      <p:grpSpPr>
+        <a:xfrm>
+          <a:off x="0" y="0"/>
+          <a:ext cx="0" cy="0"/>
+          <a:chOff x="0" y="0"/>
+          <a:chExt cx="0" cy="0"/>
+        </a:xfrm>
+      </p:grpSpPr>
+      <p:sp>
+        <p:nvSpPr>
+          <p:cNvPr id="2" name="Slide Image Placeholder 1"/>
+          <p:cNvSpPr>
+            <a:spLocks noGrp="1"/>
+          </p:cNvSpPr>
+          <p:nvPr>
+            <p:ph type="sldImg" idx="2"/>
+          </p:nvPr>
+        </p:nvSpPr>
+        <p:spPr/>
+      </p:sp>
+      <p:sp>
+        <p:nvSpPr>
+          <p:cNvPr id="3" name="Notes Placeholder 2"/>
+          <p:cNvSpPr>
+            <a:spLocks noGrp="1"/>
+          </p:cNvSpPr>
+          <p:nvPr>
+            <p:ph type="body" idx="3" sz="quarter"/>
+          </p:nvPr>
+        </p:nvSpPr>
+        <p:spPr/>
+        <p:txBody>
+          <a:bodyPr/>
+          <a:lstStyle/>
+          <a:p>
+            <a:r>
+              <a:t>TIME 0:45. End on Next Steps energy. Favorite = AI insight. Challenging = interacting state / bugs in the seams (ties to the code slide!). Land the last line, eye contact, stop. 'Thanks — happy to take questions!'</a:t>
             </a:r>
           </a:p>
         </p:txBody>
@@ -3738,13 +3809,13 @@
         <p:spPr>
           <a:xfrm>
             <a:off x="0" y="0"/>
-            <a:ext cx="12191695" cy="6858000"/>
+            <a:ext cx="164592" cy="6858000"/>
           </a:xfrm>
           <a:prstGeom prst="rect">
             <a:avLst/>
           </a:prstGeom>
           <a:solidFill>
-            <a:srgbClr val="111844"/>
+            <a:srgbClr val="EAE0CF"/>
           </a:solidFill>
           <a:ln>
             <a:noFill/>
@@ -3775,14 +3846,65 @@
       </p:sp>
       <p:sp>
         <p:nvSpPr>
-          <p:cNvPr id="3" name="Rectangle 2"/>
+          <p:cNvPr id="3" name="TextBox 2"/>
+          <p:cNvSpPr txBox="1"/>
+          <p:nvPr/>
+        </p:nvSpPr>
+        <p:spPr>
+          <a:xfrm>
+            <a:off x="731520" y="1280160"/>
+            <a:ext cx="6035040" cy="1097280"/>
+          </a:xfrm>
+          <a:prstGeom prst="rect">
+            <a:avLst/>
+          </a:prstGeom>
+          <a:noFill/>
+        </p:spPr>
+        <p:txBody>
+          <a:bodyPr wrap="square" anchor="t">
+            <a:spAutoFit/>
+          </a:bodyPr>
+          <a:lstStyle/>
+          <a:p>
+            <a:pPr algn="l">
+              <a:lnSpc>
+                <a:spcPct val="105000"/>
+              </a:lnSpc>
+              <a:spcAft>
+                <a:spcPts val="600"/>
+              </a:spcAft>
+            </a:pPr>
+            <a:r>
+              <a:rPr sz="5400" b="1">
+                <a:solidFill>
+                  <a:srgbClr val="F5F3EE"/>
+                </a:solidFill>
+                <a:latin typeface="Poppins"/>
+              </a:rPr>
+              <a:t>🎬 Flix</a:t>
+            </a:r>
+            <a:r>
+              <a:rPr sz="5400" b="1">
+                <a:solidFill>
+                  <a:srgbClr val="EAE0CF"/>
+                </a:solidFill>
+                <a:latin typeface="Poppins"/>
+              </a:rPr>
+              <a:t>ster</a:t>
+            </a:r>
+          </a:p>
+        </p:txBody>
+      </p:sp>
+      <p:sp>
+        <p:nvSpPr>
+          <p:cNvPr id="4" name="Rectangle 3"/>
           <p:cNvSpPr/>
           <p:nvPr/>
         </p:nvSpPr>
         <p:spPr>
           <a:xfrm>
-            <a:off x="0" y="0"/>
-            <a:ext cx="164592" cy="6858000"/>
+            <a:off x="777240" y="2331720"/>
+            <a:ext cx="1280160" cy="76200"/>
           </a:xfrm>
           <a:prstGeom prst="rect">
             <a:avLst/>
@@ -3819,14 +3941,14 @@
       </p:sp>
       <p:sp>
         <p:nvSpPr>
-          <p:cNvPr id="4" name="TextBox 3"/>
+          <p:cNvPr id="5" name="TextBox 4"/>
           <p:cNvSpPr txBox="1"/>
           <p:nvPr/>
         </p:nvSpPr>
         <p:spPr>
           <a:xfrm>
-            <a:off x="731520" y="1280160"/>
-            <a:ext cx="6035040" cy="1097280"/>
+            <a:off x="777240" y="2560320"/>
+            <a:ext cx="5852160" cy="457200"/>
           </a:xfrm>
           <a:prstGeom prst="rect">
             <a:avLst/>
@@ -3848,45 +3970,160 @@
               </a:spcAft>
             </a:pPr>
             <a:r>
-              <a:rPr sz="5400" b="1">
-                <a:solidFill>
-                  <a:srgbClr val="F5F3EE"/>
-                </a:solidFill>
-                <a:latin typeface="Poppins"/>
+              <a:rPr sz="2000" b="0">
+                <a:solidFill>
+                  <a:srgbClr val="C9D3E6"/>
+                </a:solidFill>
+                <a:latin typeface="Inter"/>
               </a:rPr>
-              <a:t>🎬 Flix</a:t>
-            </a:r>
-            <a:r>
-              <a:rPr sz="5400" b="1">
-                <a:solidFill>
-                  <a:srgbClr val="EAE0CF"/>
-                </a:solidFill>
-                <a:latin typeface="Poppins"/>
-              </a:rPr>
-              <a:t>ster</a:t>
-            </a:r>
-          </a:p>
-        </p:txBody>
-      </p:sp>
-      <p:sp>
-        <p:nvSpPr>
-          <p:cNvPr id="5" name="Rectangle 4"/>
-          <p:cNvSpPr/>
+              <a:t>by David Gonzalez-Cesar</a:t>
+            </a:r>
+          </a:p>
+        </p:txBody>
+      </p:sp>
+      <p:sp>
+        <p:nvSpPr>
+          <p:cNvPr id="6" name="TextBox 5"/>
+          <p:cNvSpPr txBox="1"/>
           <p:nvPr/>
         </p:nvSpPr>
         <p:spPr>
           <a:xfrm>
-            <a:off x="777240" y="2331720"/>
-            <a:ext cx="1280160" cy="76200"/>
+            <a:off x="777240" y="3108960"/>
+            <a:ext cx="5669280" cy="2194560"/>
           </a:xfrm>
           <a:prstGeom prst="rect">
             <a:avLst/>
           </a:prstGeom>
+          <a:noFill/>
+        </p:spPr>
+        <p:txBody>
+          <a:bodyPr wrap="square" anchor="t">
+            <a:spAutoFit/>
+          </a:bodyPr>
+          <a:lstStyle/>
+          <a:p>
+            <a:pPr algn="l">
+              <a:lnSpc>
+                <a:spcPct val="115000"/>
+              </a:lnSpc>
+              <a:spcAft>
+                <a:spcPts val="600"/>
+              </a:spcAft>
+            </a:pPr>
+            <a:r>
+              <a:rPr sz="2000" b="0">
+                <a:solidFill>
+                  <a:srgbClr val="F5F3EE"/>
+                </a:solidFill>
+                <a:latin typeface="Inter"/>
+              </a:rPr>
+              <a:t>A movie </a:t>
+            </a:r>
+            <a:r>
+              <a:rPr sz="2000" b="1">
+                <a:solidFill>
+                  <a:srgbClr val="EAE0CF"/>
+                </a:solidFill>
+                <a:latin typeface="Inter"/>
+              </a:rPr>
+              <a:t>discovery</a:t>
+            </a:r>
+            <a:r>
+              <a:rPr sz="2000" b="0">
+                <a:solidFill>
+                  <a:srgbClr val="F5F3EE"/>
+                </a:solidFill>
+                <a:latin typeface="Inter"/>
+              </a:rPr>
+              <a:t> app — decide what to see in theaters tonight. It pulls what's now playing from The Movie Database, lets you search and sort, and gives an AI </a:t>
+            </a:r>
+            <a:r>
+              <a:rPr sz="2000" b="1">
+                <a:solidFill>
+                  <a:srgbClr val="EAE0CF"/>
+                </a:solidFill>
+                <a:latin typeface="Inter"/>
+              </a:rPr>
+              <a:t>“Worth seeing?”</a:t>
+            </a:r>
+            <a:r>
+              <a:rPr sz="2000" b="0">
+                <a:solidFill>
+                  <a:srgbClr val="F5F3EE"/>
+                </a:solidFill>
+                <a:latin typeface="Inter"/>
+              </a:rPr>
+              <a:t> take on every film.</a:t>
+            </a:r>
+          </a:p>
+        </p:txBody>
+      </p:sp>
+      <p:sp>
+        <p:nvSpPr>
+          <p:cNvPr id="7" name="TextBox 6"/>
+          <p:cNvSpPr txBox="1"/>
+          <p:nvPr/>
+        </p:nvSpPr>
+        <p:spPr>
+          <a:xfrm>
+            <a:off x="777240" y="5669280"/>
+            <a:ext cx="6400800" cy="457200"/>
+          </a:xfrm>
+          <a:prstGeom prst="rect">
+            <a:avLst/>
+          </a:prstGeom>
+          <a:noFill/>
+        </p:spPr>
+        <p:txBody>
+          <a:bodyPr wrap="square" anchor="t">
+            <a:spAutoFit/>
+          </a:bodyPr>
+          <a:lstStyle/>
+          <a:p>
+            <a:pPr algn="l">
+              <a:lnSpc>
+                <a:spcPct val="105000"/>
+              </a:lnSpc>
+              <a:spcAft>
+                <a:spcPts val="600"/>
+              </a:spcAft>
+            </a:pPr>
+            <a:r>
+              <a:rPr sz="1300" b="0">
+                <a:solidFill>
+                  <a:srgbClr val="7288AE"/>
+                </a:solidFill>
+                <a:latin typeface="Inter"/>
+              </a:rPr>
+              <a:t>React + Vite · TMDb + OpenRouter · running locally (npm run dev)</a:t>
+            </a:r>
+          </a:p>
+        </p:txBody>
+      </p:sp>
+      <p:sp>
+        <p:nvSpPr>
+          <p:cNvPr id="8" name="Rounded Rectangle 7"/>
+          <p:cNvSpPr/>
+          <p:nvPr/>
+        </p:nvSpPr>
+        <p:spPr>
+          <a:xfrm>
+            <a:off x="7315200" y="1280160"/>
+            <a:ext cx="4114800" cy="4206240"/>
+          </a:xfrm>
+          <a:prstGeom prst="roundRect">
+            <a:avLst>
+              <a:gd name="adj" fmla="val 5000"/>
+            </a:avLst>
+          </a:prstGeom>
           <a:solidFill>
-            <a:srgbClr val="EAE0CF"/>
+            <a:srgbClr val="0A0E2A"/>
           </a:solidFill>
-          <a:ln>
-            <a:noFill/>
+          <a:ln w="12700">
+            <a:solidFill>
+              <a:srgbClr val="4B5694"/>
+            </a:solidFill>
           </a:ln>
           <a:effectLst/>
         </p:spPr>
@@ -3914,217 +4151,7 @@
       </p:sp>
       <p:sp>
         <p:nvSpPr>
-          <p:cNvPr id="6" name="TextBox 5"/>
-          <p:cNvSpPr txBox="1"/>
-          <p:nvPr/>
-        </p:nvSpPr>
-        <p:spPr>
-          <a:xfrm>
-            <a:off x="777240" y="2560320"/>
-            <a:ext cx="5852160" cy="457200"/>
-          </a:xfrm>
-          <a:prstGeom prst="rect">
-            <a:avLst/>
-          </a:prstGeom>
-          <a:noFill/>
-        </p:spPr>
-        <p:txBody>
-          <a:bodyPr wrap="square" anchor="t">
-            <a:spAutoFit/>
-          </a:bodyPr>
-          <a:lstStyle/>
-          <a:p>
-            <a:pPr algn="l">
-              <a:lnSpc>
-                <a:spcPct val="105000"/>
-              </a:lnSpc>
-              <a:spcAft>
-                <a:spcPts val="600"/>
-              </a:spcAft>
-            </a:pPr>
-            <a:r>
-              <a:rPr sz="2000" b="0">
-                <a:solidFill>
-                  <a:srgbClr val="C9D3E6"/>
-                </a:solidFill>
-                <a:latin typeface="Inter"/>
-              </a:rPr>
-              <a:t>by David Gonzalez-Cesar</a:t>
-            </a:r>
-          </a:p>
-        </p:txBody>
-      </p:sp>
-      <p:sp>
-        <p:nvSpPr>
-          <p:cNvPr id="7" name="TextBox 6"/>
-          <p:cNvSpPr txBox="1"/>
-          <p:nvPr/>
-        </p:nvSpPr>
-        <p:spPr>
-          <a:xfrm>
-            <a:off x="777240" y="3108960"/>
-            <a:ext cx="5669280" cy="2194560"/>
-          </a:xfrm>
-          <a:prstGeom prst="rect">
-            <a:avLst/>
-          </a:prstGeom>
-          <a:noFill/>
-        </p:spPr>
-        <p:txBody>
-          <a:bodyPr wrap="square" anchor="t">
-            <a:spAutoFit/>
-          </a:bodyPr>
-          <a:lstStyle/>
-          <a:p>
-            <a:pPr algn="l">
-              <a:lnSpc>
-                <a:spcPct val="115000"/>
-              </a:lnSpc>
-              <a:spcAft>
-                <a:spcPts val="600"/>
-              </a:spcAft>
-            </a:pPr>
-            <a:r>
-              <a:rPr sz="2000" b="0">
-                <a:solidFill>
-                  <a:srgbClr val="F5F3EE"/>
-                </a:solidFill>
-                <a:latin typeface="Inter"/>
-              </a:rPr>
-              <a:t>A movie </a:t>
-            </a:r>
-            <a:r>
-              <a:rPr sz="2000" b="1">
-                <a:solidFill>
-                  <a:srgbClr val="EAE0CF"/>
-                </a:solidFill>
-                <a:latin typeface="Inter"/>
-              </a:rPr>
-              <a:t>discovery</a:t>
-            </a:r>
-            <a:r>
-              <a:rPr sz="2000" b="0">
-                <a:solidFill>
-                  <a:srgbClr val="F5F3EE"/>
-                </a:solidFill>
-                <a:latin typeface="Inter"/>
-              </a:rPr>
-              <a:t> app — decide what to see in theaters tonight. It pulls what's now playing from The Movie Database, lets you search and sort, and gives an AI </a:t>
-            </a:r>
-            <a:r>
-              <a:rPr sz="2000" b="1">
-                <a:solidFill>
-                  <a:srgbClr val="EAE0CF"/>
-                </a:solidFill>
-                <a:latin typeface="Inter"/>
-              </a:rPr>
-              <a:t>“Worth seeing?”</a:t>
-            </a:r>
-            <a:r>
-              <a:rPr sz="2000" b="0">
-                <a:solidFill>
-                  <a:srgbClr val="F5F3EE"/>
-                </a:solidFill>
-                <a:latin typeface="Inter"/>
-              </a:rPr>
-              <a:t> take on every film.</a:t>
-            </a:r>
-          </a:p>
-        </p:txBody>
-      </p:sp>
-      <p:sp>
-        <p:nvSpPr>
-          <p:cNvPr id="8" name="TextBox 7"/>
-          <p:cNvSpPr txBox="1"/>
-          <p:nvPr/>
-        </p:nvSpPr>
-        <p:spPr>
-          <a:xfrm>
-            <a:off x="777240" y="5669280"/>
-            <a:ext cx="6400800" cy="457200"/>
-          </a:xfrm>
-          <a:prstGeom prst="rect">
-            <a:avLst/>
-          </a:prstGeom>
-          <a:noFill/>
-        </p:spPr>
-        <p:txBody>
-          <a:bodyPr wrap="square" anchor="t">
-            <a:spAutoFit/>
-          </a:bodyPr>
-          <a:lstStyle/>
-          <a:p>
-            <a:pPr algn="l">
-              <a:lnSpc>
-                <a:spcPct val="105000"/>
-              </a:lnSpc>
-              <a:spcAft>
-                <a:spcPts val="600"/>
-              </a:spcAft>
-            </a:pPr>
-            <a:r>
-              <a:rPr sz="1300" b="0">
-                <a:solidFill>
-                  <a:srgbClr val="7288AE"/>
-                </a:solidFill>
-                <a:latin typeface="Inter"/>
-              </a:rPr>
-              <a:t>React + Vite · TMDb + OpenRouter · running locally (npm run dev)</a:t>
-            </a:r>
-          </a:p>
-        </p:txBody>
-      </p:sp>
-      <p:sp>
-        <p:nvSpPr>
-          <p:cNvPr id="9" name="Rounded Rectangle 8"/>
-          <p:cNvSpPr/>
-          <p:nvPr/>
-        </p:nvSpPr>
-        <p:spPr>
-          <a:xfrm>
-            <a:off x="7315200" y="1280160"/>
-            <a:ext cx="4114800" cy="4206240"/>
-          </a:xfrm>
-          <a:prstGeom prst="roundRect">
-            <a:avLst>
-              <a:gd name="adj" fmla="val 6000"/>
-            </a:avLst>
-          </a:prstGeom>
-          <a:solidFill>
-            <a:srgbClr val="0A0E2A"/>
-          </a:solidFill>
-          <a:ln w="12700">
-            <a:solidFill>
-              <a:srgbClr val="4B5694"/>
-            </a:solidFill>
-          </a:ln>
-          <a:effectLst/>
-        </p:spPr>
-        <p:style>
-          <a:lnRef idx="1">
-            <a:schemeClr val="accent1"/>
-          </a:lnRef>
-          <a:fillRef idx="3">
-            <a:schemeClr val="accent1"/>
-          </a:fillRef>
-          <a:effectRef idx="2">
-            <a:schemeClr val="accent1"/>
-          </a:effectRef>
-          <a:fontRef idx="minor">
-            <a:schemeClr val="lt1"/>
-          </a:fontRef>
-        </p:style>
-        <p:txBody>
-          <a:bodyPr rtlCol="0" anchor="ctr"/>
-          <a:lstStyle/>
-          <a:p>
-            <a:pPr algn="ctr"/>
-          </a:p>
-        </p:txBody>
-      </p:sp>
-      <p:sp>
-        <p:nvSpPr>
-          <p:cNvPr id="10" name="TextBox 9"/>
+          <p:cNvPr id="9" name="TextBox 8"/>
           <p:cNvSpPr txBox="1"/>
           <p:nvPr/>
         </p:nvSpPr>
@@ -4243,7 +4270,7 @@
         <p:spPr>
           <a:xfrm>
             <a:off x="731520" y="457200"/>
-            <a:ext cx="7315200" cy="822960"/>
+            <a:ext cx="10058400" cy="822960"/>
           </a:xfrm>
           <a:prstGeom prst="rect">
             <a:avLst/>
@@ -4519,7 +4546,7 @@
                 </a:solidFill>
                 <a:latin typeface="Inter"/>
               </a:rPr>
-              <a:t>2nd API call + AI “Worth seeing?”</a:t>
+              <a:t>2nd API call + AI “Worth seeing?” + trailer</a:t>
             </a:r>
           </a:p>
         </p:txBody>
@@ -4690,7 +4717,7 @@
           </a:xfrm>
           <a:prstGeom prst="roundRect">
             <a:avLst>
-              <a:gd name="adj" fmla="val 6000"/>
+              <a:gd name="adj" fmla="val 5000"/>
             </a:avLst>
           </a:prstGeom>
           <a:solidFill>
@@ -4847,7 +4874,7 @@
         <p:spPr>
           <a:xfrm>
             <a:off x="731520" y="457200"/>
-            <a:ext cx="9144000" cy="822960"/>
+            <a:ext cx="10058400" cy="822960"/>
           </a:xfrm>
           <a:prstGeom prst="rect">
             <a:avLst/>
@@ -5109,7 +5136,7 @@
                 </a:solidFill>
                 <a:latin typeface="Inter"/>
               </a:rPr>
-              <a:t>TMDb for movie data + OpenRouter for the AI “Worth seeing?” take</a:t>
+              <a:t>TMDb for movies + OpenRouter for the AI “Worth seeing?” take</a:t>
             </a:r>
           </a:p>
         </p:txBody>
@@ -5299,7 +5326,7 @@
                 </a:solidFill>
                 <a:latin typeface="Inter"/>
               </a:rPr>
-              <a:t>AI degrades gracefully; adversarial code review caught real bugs — event bubbling, an async race, keyboard accessibility</a:t>
+              <a:t>AI falls back gracefully; adversarial code review caught real bugs — event bubbling, an async race, keyboard accessibility</a:t>
             </a:r>
           </a:p>
         </p:txBody>
@@ -5383,7 +5410,7 @@
         <p:spPr>
           <a:xfrm>
             <a:off x="731520" y="457200"/>
-            <a:ext cx="9144000" cy="822960"/>
+            <a:ext cx="10058400" cy="822960"/>
           </a:xfrm>
           <a:prstGeom prst="rect">
             <a:avLst/>
@@ -5411,7 +5438,7 @@
                 </a:solidFill>
                 <a:latin typeface="Poppins"/>
               </a:rPr>
-              <a:t>Reflection</a:t>
+              <a:t>Code spotlight: immutable state</a:t>
             </a:r>
           </a:p>
         </p:txBody>
@@ -5462,25 +5489,69 @@
       </p:sp>
       <p:sp>
         <p:nvSpPr>
-          <p:cNvPr id="5" name="Rounded Rectangle 4"/>
+          <p:cNvPr id="5" name="TextBox 4"/>
+          <p:cNvSpPr txBox="1"/>
+          <p:nvPr/>
+        </p:nvSpPr>
+        <p:spPr>
+          <a:xfrm>
+            <a:off x="777240" y="1600200"/>
+            <a:ext cx="10424160" cy="457200"/>
+          </a:xfrm>
+          <a:prstGeom prst="rect">
+            <a:avLst/>
+          </a:prstGeom>
+          <a:noFill/>
+        </p:spPr>
+        <p:txBody>
+          <a:bodyPr wrap="square" anchor="t">
+            <a:spAutoFit/>
+          </a:bodyPr>
+          <a:lstStyle/>
+          <a:p>
+            <a:pPr algn="l">
+              <a:lnSpc>
+                <a:spcPct val="105000"/>
+              </a:lnSpc>
+              <a:spcAft>
+                <a:spcPts val="600"/>
+              </a:spcAft>
+            </a:pPr>
+            <a:r>
+              <a:rPr sz="1600" b="0">
+                <a:solidFill>
+                  <a:srgbClr val="C9D3E6"/>
+                </a:solidFill>
+                <a:latin typeface="Inter"/>
+              </a:rPr>
+              <a:t>The bug I had to avoid in the “seams”: mutating React state in place.</a:t>
+            </a:r>
+          </a:p>
+        </p:txBody>
+      </p:sp>
+      <p:sp>
+        <p:nvSpPr>
+          <p:cNvPr id="6" name="Rounded Rectangle 5"/>
           <p:cNvSpPr/>
           <p:nvPr/>
         </p:nvSpPr>
         <p:spPr>
           <a:xfrm>
-            <a:off x="777240" y="1828800"/>
-            <a:ext cx="3520440" cy="4206240"/>
+            <a:off x="777240" y="2148840"/>
+            <a:ext cx="6949440" cy="3383280"/>
           </a:xfrm>
           <a:prstGeom prst="roundRect">
             <a:avLst>
-              <a:gd name="adj" fmla="val 6000"/>
+              <a:gd name="adj" fmla="val 5000"/>
             </a:avLst>
           </a:prstGeom>
           <a:solidFill>
-            <a:srgbClr val="262F63"/>
+            <a:srgbClr val="0A0E2A"/>
           </a:solidFill>
-          <a:ln>
-            <a:noFill/>
+          <a:ln w="12700">
+            <a:solidFill>
+              <a:srgbClr val="4B5694"/>
+            </a:solidFill>
           </a:ln>
           <a:effectLst/>
         </p:spPr>
@@ -5499,60 +5570,189 @@
           </a:fontRef>
         </p:style>
         <p:txBody>
-          <a:bodyPr rtlCol="0" anchor="t" wrap="square" lIns="256032" rIns="256032" tIns="256032"/>
+          <a:bodyPr rtlCol="0" anchor="ctr" wrap="square" lIns="274320" tIns="228600" rIns="182880"/>
           <a:lstStyle/>
           <a:p>
             <a:pPr algn="ctr">
+              <a:lnSpc>
+                <a:spcPct val="125000"/>
+              </a:lnSpc>
               <a:spcAft>
-                <a:spcPts val="1400"/>
+                <a:spcPts val="0"/>
               </a:spcAft>
             </a:pPr>
             <a:r>
-              <a:rPr sz="2000" b="1">
-                <a:solidFill>
-                  <a:srgbClr val="EAE0CF"/>
-                </a:solidFill>
-                <a:latin typeface="Poppins"/>
+              <a:rPr sz="1500" i="0">
+                <a:solidFill>
+                  <a:srgbClr val="DDE7C8"/>
+                </a:solidFill>
+                <a:latin typeface="Consolas"/>
               </a:rPr>
-              <a:t>⭐ Favorite Feature</a:t>
+              <a:t>const toggleFavorite = (id) =&gt; {</a:t>
             </a:r>
           </a:p>
           <a:p>
             <a:pPr>
               <a:lnSpc>
-                <a:spcPct val="118000"/>
+                <a:spcPct val="125000"/>
               </a:lnSpc>
+              <a:spcAft>
+                <a:spcPts val="0"/>
+              </a:spcAft>
             </a:pPr>
             <a:r>
-              <a:rPr sz="1500">
-                <a:solidFill>
-                  <a:srgbClr val="F5F3EE"/>
-                </a:solidFill>
-                <a:latin typeface="Inter"/>
+              <a:rPr sz="1500" i="0">
+                <a:solidFill>
+                  <a:srgbClr val="DDE7C8"/>
+                </a:solidFill>
+                <a:latin typeface="Consolas"/>
               </a:rPr>
-              <a:t>The AI “Worth seeing?” insight — it makes this a discovery tool, not just a list. Taught me to handle async AI calls with loading + fallback states.</a:t>
-            </a:r>
-          </a:p>
-        </p:txBody>
-      </p:sp>
-      <p:sp>
-        <p:nvSpPr>
-          <p:cNvPr id="6" name="Rounded Rectangle 5"/>
+              <a:t>  setFavorites((prev) =&gt; {</a:t>
+            </a:r>
+          </a:p>
+          <a:p>
+            <a:pPr>
+              <a:lnSpc>
+                <a:spcPct val="125000"/>
+              </a:lnSpc>
+              <a:spcAft>
+                <a:spcPts val="0"/>
+              </a:spcAft>
+            </a:pPr>
+            <a:r>
+              <a:rPr sz="1500" i="0">
+                <a:solidFill>
+                  <a:srgbClr val="DDE7C8"/>
+                </a:solidFill>
+                <a:latin typeface="Consolas"/>
+              </a:rPr>
+              <a:t>    const next = new Set(prev)  </a:t>
+            </a:r>
+            <a:r>
+              <a:rPr sz="1500" i="1">
+                <a:solidFill>
+                  <a:srgbClr val="828EB0"/>
+                </a:solidFill>
+                <a:latin typeface="Consolas"/>
+              </a:rPr>
+              <a:t>// NEW Set → new identity → re-render</a:t>
+            </a:r>
+          </a:p>
+          <a:p>
+            <a:pPr>
+              <a:lnSpc>
+                <a:spcPct val="125000"/>
+              </a:lnSpc>
+              <a:spcAft>
+                <a:spcPts val="0"/>
+              </a:spcAft>
+            </a:pPr>
+            <a:r>
+              <a:rPr sz="1500" i="0">
+                <a:solidFill>
+                  <a:srgbClr val="DDE7C8"/>
+                </a:solidFill>
+                <a:latin typeface="Consolas"/>
+              </a:rPr>
+              <a:t>    if (next.has(id)) next.delete(id)</a:t>
+            </a:r>
+          </a:p>
+          <a:p>
+            <a:pPr>
+              <a:lnSpc>
+                <a:spcPct val="125000"/>
+              </a:lnSpc>
+              <a:spcAft>
+                <a:spcPts val="0"/>
+              </a:spcAft>
+            </a:pPr>
+            <a:r>
+              <a:rPr sz="1500" i="0">
+                <a:solidFill>
+                  <a:srgbClr val="DDE7C8"/>
+                </a:solidFill>
+                <a:latin typeface="Consolas"/>
+              </a:rPr>
+              <a:t>    else next.add(id)</a:t>
+            </a:r>
+          </a:p>
+          <a:p>
+            <a:pPr>
+              <a:lnSpc>
+                <a:spcPct val="125000"/>
+              </a:lnSpc>
+              <a:spcAft>
+                <a:spcPts val="0"/>
+              </a:spcAft>
+            </a:pPr>
+            <a:r>
+              <a:rPr sz="1500" i="0">
+                <a:solidFill>
+                  <a:srgbClr val="DDE7C8"/>
+                </a:solidFill>
+                <a:latin typeface="Consolas"/>
+              </a:rPr>
+              <a:t>    return next</a:t>
+            </a:r>
+          </a:p>
+          <a:p>
+            <a:pPr>
+              <a:lnSpc>
+                <a:spcPct val="125000"/>
+              </a:lnSpc>
+              <a:spcAft>
+                <a:spcPts val="0"/>
+              </a:spcAft>
+            </a:pPr>
+            <a:r>
+              <a:rPr sz="1500" i="0">
+                <a:solidFill>
+                  <a:srgbClr val="DDE7C8"/>
+                </a:solidFill>
+                <a:latin typeface="Consolas"/>
+              </a:rPr>
+              <a:t>  })</a:t>
+            </a:r>
+          </a:p>
+          <a:p>
+            <a:pPr>
+              <a:lnSpc>
+                <a:spcPct val="125000"/>
+              </a:lnSpc>
+              <a:spcAft>
+                <a:spcPts val="0"/>
+              </a:spcAft>
+            </a:pPr>
+            <a:r>
+              <a:rPr sz="1500" i="0">
+                <a:solidFill>
+                  <a:srgbClr val="DDE7C8"/>
+                </a:solidFill>
+                <a:latin typeface="Consolas"/>
+              </a:rPr>
+              <a:t>}</a:t>
+            </a:r>
+          </a:p>
+        </p:txBody>
+      </p:sp>
+      <p:sp>
+        <p:nvSpPr>
+          <p:cNvPr id="7" name="Rounded Rectangle 6"/>
           <p:cNvSpPr/>
           <p:nvPr/>
         </p:nvSpPr>
         <p:spPr>
           <a:xfrm>
-            <a:off x="4590288" y="1828800"/>
-            <a:ext cx="3520440" cy="4206240"/>
+            <a:off x="7955279" y="2148840"/>
+            <a:ext cx="3474720" cy="3383280"/>
           </a:xfrm>
           <a:prstGeom prst="roundRect">
             <a:avLst>
-              <a:gd name="adj" fmla="val 6000"/>
+              <a:gd name="adj" fmla="val 5000"/>
             </a:avLst>
           </a:prstGeom>
           <a:solidFill>
-            <a:srgbClr val="213A40"/>
+            <a:srgbClr val="262F63"/>
           </a:solidFill>
           <a:ln>
             <a:noFill/>
@@ -5574,22 +5774,22 @@
           </a:fontRef>
         </p:style>
         <p:txBody>
-          <a:bodyPr rtlCol="0" anchor="t" wrap="square" lIns="256032" rIns="256032" tIns="256032"/>
+          <a:bodyPr rtlCol="0" anchor="ctr" wrap="square" lIns="256032" rIns="256032" tIns="256032"/>
           <a:lstStyle/>
           <a:p>
             <a:pPr algn="ctr">
               <a:spcAft>
-                <a:spcPts val="1400"/>
+                <a:spcPts val="1200"/>
               </a:spcAft>
             </a:pPr>
             <a:r>
-              <a:rPr sz="2000" b="1">
+              <a:rPr sz="1800" b="1">
                 <a:solidFill>
                   <a:srgbClr val="EAE0CF"/>
                 </a:solidFill>
                 <a:latin typeface="Poppins"/>
               </a:rPr>
-              <a:t>🧗 Most Challenging</a:t>
+              <a:t>Why it matters</a:t>
             </a:r>
           </a:p>
           <a:p>
@@ -5597,37 +5797,144 @@
               <a:lnSpc>
                 <a:spcPct val="118000"/>
               </a:lnSpc>
+              <a:spcAft>
+                <a:spcPts val="800"/>
+              </a:spcAft>
             </a:pPr>
             <a:r>
-              <a:rPr sz="1500">
+              <a:rPr sz="1200">
                 <a:solidFill>
                   <a:srgbClr val="F5F3EE"/>
                 </a:solidFill>
                 <a:latin typeface="Inter"/>
               </a:rPr>
-              <a:t>State that interacts — favorites, filter, search &amp; sort all touch each other. The bugs hid in the seams; a review found 11 issues in the sidebar alone (an async race, keyboard focus traps).</a:t>
-            </a:r>
-          </a:p>
-        </p:txBody>
-      </p:sp>
-      <p:sp>
-        <p:nvSpPr>
-          <p:cNvPr id="7" name="Rounded Rectangle 6"/>
+              <a:t>React compares state by reference. Mutating the old Set keeps the same identity → React skips the re-render → the star toggles in memory but the UI goes stale.</a:t>
+            </a:r>
+          </a:p>
+          <a:p>
+            <a:pPr>
+              <a:lnSpc>
+                <a:spcPct val="118000"/>
+              </a:lnSpc>
+              <a:spcAft>
+                <a:spcPts val="800"/>
+              </a:spcAft>
+            </a:pPr>
+            <a:r>
+              <a:rPr sz="1200">
+                <a:solidFill>
+                  <a:srgbClr val="F5F3EE"/>
+                </a:solidFill>
+                <a:latin typeface="Inter"/>
+              </a:rPr>
+              <a:t>So I copy → toggle → return a new Set. New reference = guaranteed re-render.</a:t>
+            </a:r>
+          </a:p>
+          <a:p>
+            <a:pPr>
+              <a:lnSpc>
+                <a:spcPct val="118000"/>
+              </a:lnSpc>
+              <a:spcAft>
+                <a:spcPts val="800"/>
+              </a:spcAft>
+            </a:pPr>
+            <a:r>
+              <a:rPr sz="1200">
+                <a:solidFill>
+                  <a:srgbClr val="F5F3EE"/>
+                </a:solidFill>
+                <a:latin typeface="Inter"/>
+              </a:rPr>
+              <a:t>The prev =&gt; … updater always reads the latest state, never a stale closure.</a:t>
+            </a:r>
+          </a:p>
+        </p:txBody>
+      </p:sp>
+      <p:sp>
+        <p:nvSpPr>
+          <p:cNvPr id="8" name="TextBox 7"/>
+          <p:cNvSpPr txBox="1"/>
+          <p:nvPr/>
+        </p:nvSpPr>
+        <p:spPr>
+          <a:xfrm>
+            <a:off x="777240" y="5669280"/>
+            <a:ext cx="10424160" cy="548640"/>
+          </a:xfrm>
+          <a:prstGeom prst="rect">
+            <a:avLst/>
+          </a:prstGeom>
+          <a:noFill/>
+        </p:spPr>
+        <p:txBody>
+          <a:bodyPr wrap="square" anchor="t">
+            <a:spAutoFit/>
+          </a:bodyPr>
+          <a:lstStyle/>
+          <a:p>
+            <a:pPr algn="l">
+              <a:lnSpc>
+                <a:spcPct val="105000"/>
+              </a:lnSpc>
+              <a:spcAft>
+                <a:spcPts val="600"/>
+              </a:spcAft>
+            </a:pPr>
+            <a:r>
+              <a:rPr sz="1300" b="0">
+                <a:solidFill>
+                  <a:srgbClr val="7288AE"/>
+                </a:solidFill>
+                <a:latin typeface="Inter"/>
+              </a:rPr>
+              <a:t>Favorites is the state filter, search, and sort all read — immutable updates kept it from desyncing while everything re-rendered around it.</a:t>
+            </a:r>
+          </a:p>
+        </p:txBody>
+      </p:sp>
+    </p:spTree>
+  </p:cSld>
+  <p:clrMapOvr>
+    <a:masterClrMapping/>
+  </p:clrMapOvr>
+</p:sld>
+</file>
+
+<file path=ppt/slides/slide5.xml><?xml version="1.0" encoding="utf-8"?>
+<p:sld xmlns:a="http://schemas.openxmlformats.org/drawingml/2006/main" xmlns:p="http://schemas.openxmlformats.org/presentationml/2006/main" xmlns:r="http://schemas.openxmlformats.org/officeDocument/2006/relationships">
+  <p:cSld>
+    <p:bg>
+      <p:bgPr>
+        <a:solidFill>
+          <a:srgbClr val="111844"/>
+        </a:solidFill>
+        <a:effectLst/>
+      </p:bgPr>
+    </p:bg>
+    <p:spTree>
+      <p:nvGrpSpPr>
+        <p:cNvPr id="1" name=""/>
+        <p:cNvGrpSpPr/>
+        <p:nvPr/>
+      </p:nvGrpSpPr>
+      <p:grpSpPr/>
+      <p:sp>
+        <p:nvSpPr>
+          <p:cNvPr id="2" name="Rectangle 1"/>
           <p:cNvSpPr/>
           <p:nvPr/>
         </p:nvSpPr>
         <p:spPr>
           <a:xfrm>
-            <a:off x="8403336" y="1828800"/>
-            <a:ext cx="3520440" cy="4206240"/>
-          </a:xfrm>
-          <a:prstGeom prst="roundRect">
-            <a:avLst>
-              <a:gd name="adj" fmla="val 6000"/>
-            </a:avLst>
+            <a:off x="0" y="0"/>
+            <a:ext cx="164592" cy="6858000"/>
+          </a:xfrm>
+          <a:prstGeom prst="rect">
+            <a:avLst/>
           </a:prstGeom>
           <a:solidFill>
-            <a:srgbClr val="4A422E"/>
+            <a:srgbClr val="EAE0CF"/>
           </a:solidFill>
           <a:ln>
             <a:noFill/>
@@ -5649,6 +5956,138 @@
           </a:fontRef>
         </p:style>
         <p:txBody>
+          <a:bodyPr rtlCol="0" anchor="ctr"/>
+          <a:lstStyle/>
+          <a:p>
+            <a:pPr algn="ctr"/>
+          </a:p>
+        </p:txBody>
+      </p:sp>
+      <p:sp>
+        <p:nvSpPr>
+          <p:cNvPr id="3" name="TextBox 2"/>
+          <p:cNvSpPr txBox="1"/>
+          <p:nvPr/>
+        </p:nvSpPr>
+        <p:spPr>
+          <a:xfrm>
+            <a:off x="731520" y="457200"/>
+            <a:ext cx="10058400" cy="822960"/>
+          </a:xfrm>
+          <a:prstGeom prst="rect">
+            <a:avLst/>
+          </a:prstGeom>
+          <a:noFill/>
+        </p:spPr>
+        <p:txBody>
+          <a:bodyPr wrap="square" anchor="t">
+            <a:spAutoFit/>
+          </a:bodyPr>
+          <a:lstStyle/>
+          <a:p>
+            <a:pPr algn="l">
+              <a:lnSpc>
+                <a:spcPct val="105000"/>
+              </a:lnSpc>
+              <a:spcAft>
+                <a:spcPts val="600"/>
+              </a:spcAft>
+            </a:pPr>
+            <a:r>
+              <a:rPr sz="4000" b="1">
+                <a:solidFill>
+                  <a:srgbClr val="F5F3EE"/>
+                </a:solidFill>
+                <a:latin typeface="Poppins"/>
+              </a:rPr>
+              <a:t>Reflection</a:t>
+            </a:r>
+          </a:p>
+        </p:txBody>
+      </p:sp>
+      <p:sp>
+        <p:nvSpPr>
+          <p:cNvPr id="4" name="Rectangle 3"/>
+          <p:cNvSpPr/>
+          <p:nvPr/>
+        </p:nvSpPr>
+        <p:spPr>
+          <a:xfrm>
+            <a:off x="777240" y="1325880"/>
+            <a:ext cx="1280160" cy="76200"/>
+          </a:xfrm>
+          <a:prstGeom prst="rect">
+            <a:avLst/>
+          </a:prstGeom>
+          <a:solidFill>
+            <a:srgbClr val="EAE0CF"/>
+          </a:solidFill>
+          <a:ln>
+            <a:noFill/>
+          </a:ln>
+          <a:effectLst/>
+        </p:spPr>
+        <p:style>
+          <a:lnRef idx="1">
+            <a:schemeClr val="accent1"/>
+          </a:lnRef>
+          <a:fillRef idx="3">
+            <a:schemeClr val="accent1"/>
+          </a:fillRef>
+          <a:effectRef idx="2">
+            <a:schemeClr val="accent1"/>
+          </a:effectRef>
+          <a:fontRef idx="minor">
+            <a:schemeClr val="lt1"/>
+          </a:fontRef>
+        </p:style>
+        <p:txBody>
+          <a:bodyPr rtlCol="0" anchor="ctr"/>
+          <a:lstStyle/>
+          <a:p>
+            <a:pPr algn="ctr"/>
+          </a:p>
+        </p:txBody>
+      </p:sp>
+      <p:sp>
+        <p:nvSpPr>
+          <p:cNvPr id="5" name="Rounded Rectangle 4"/>
+          <p:cNvSpPr/>
+          <p:nvPr/>
+        </p:nvSpPr>
+        <p:spPr>
+          <a:xfrm>
+            <a:off x="777240" y="1828800"/>
+            <a:ext cx="3520440" cy="4206240"/>
+          </a:xfrm>
+          <a:prstGeom prst="roundRect">
+            <a:avLst>
+              <a:gd name="adj" fmla="val 5000"/>
+            </a:avLst>
+          </a:prstGeom>
+          <a:solidFill>
+            <a:srgbClr val="262F63"/>
+          </a:solidFill>
+          <a:ln>
+            <a:noFill/>
+          </a:ln>
+          <a:effectLst/>
+        </p:spPr>
+        <p:style>
+          <a:lnRef idx="1">
+            <a:schemeClr val="accent1"/>
+          </a:lnRef>
+          <a:fillRef idx="3">
+            <a:schemeClr val="accent1"/>
+          </a:fillRef>
+          <a:effectRef idx="2">
+            <a:schemeClr val="accent1"/>
+          </a:effectRef>
+          <a:fontRef idx="minor">
+            <a:schemeClr val="lt1"/>
+          </a:fontRef>
+        </p:style>
+        <p:txBody>
           <a:bodyPr rtlCol="0" anchor="t" wrap="square" lIns="256032" rIns="256032" tIns="256032"/>
           <a:lstStyle/>
           <a:p>
@@ -5664,7 +6103,7 @@
                 </a:solidFill>
                 <a:latin typeface="Poppins"/>
               </a:rPr>
-              <a:t>🚀 Next Steps</a:t>
+              <a:t>⭐ Favorite Feature</a:t>
             </a:r>
           </a:p>
           <a:p>
@@ -5680,7 +6119,157 @@
                 </a:solidFill>
                 <a:latin typeface="Inter"/>
               </a:rPr>
-              <a:t>Deploy to Render for a live link · embed YouTube trailers in the modal · persist favorites in localStorage so they survive a reload.</a:t>
+              <a:t>The AI “Worth seeing?” insight — it makes this a discovery tool, not just a list. Taught me to handle async AI calls with loading + fallback states.</a:t>
+            </a:r>
+          </a:p>
+        </p:txBody>
+      </p:sp>
+      <p:sp>
+        <p:nvSpPr>
+          <p:cNvPr id="6" name="Rounded Rectangle 5"/>
+          <p:cNvSpPr/>
+          <p:nvPr/>
+        </p:nvSpPr>
+        <p:spPr>
+          <a:xfrm>
+            <a:off x="4590288" y="1828800"/>
+            <a:ext cx="3520440" cy="4206240"/>
+          </a:xfrm>
+          <a:prstGeom prst="roundRect">
+            <a:avLst>
+              <a:gd name="adj" fmla="val 5000"/>
+            </a:avLst>
+          </a:prstGeom>
+          <a:solidFill>
+            <a:srgbClr val="213A40"/>
+          </a:solidFill>
+          <a:ln>
+            <a:noFill/>
+          </a:ln>
+          <a:effectLst/>
+        </p:spPr>
+        <p:style>
+          <a:lnRef idx="1">
+            <a:schemeClr val="accent1"/>
+          </a:lnRef>
+          <a:fillRef idx="3">
+            <a:schemeClr val="accent1"/>
+          </a:fillRef>
+          <a:effectRef idx="2">
+            <a:schemeClr val="accent1"/>
+          </a:effectRef>
+          <a:fontRef idx="minor">
+            <a:schemeClr val="lt1"/>
+          </a:fontRef>
+        </p:style>
+        <p:txBody>
+          <a:bodyPr rtlCol="0" anchor="t" wrap="square" lIns="256032" rIns="256032" tIns="256032"/>
+          <a:lstStyle/>
+          <a:p>
+            <a:pPr algn="ctr">
+              <a:spcAft>
+                <a:spcPts val="1400"/>
+              </a:spcAft>
+            </a:pPr>
+            <a:r>
+              <a:rPr sz="2000" b="1">
+                <a:solidFill>
+                  <a:srgbClr val="EAE0CF"/>
+                </a:solidFill>
+                <a:latin typeface="Poppins"/>
+              </a:rPr>
+              <a:t>🧗 Most Challenging</a:t>
+            </a:r>
+          </a:p>
+          <a:p>
+            <a:pPr>
+              <a:lnSpc>
+                <a:spcPct val="118000"/>
+              </a:lnSpc>
+            </a:pPr>
+            <a:r>
+              <a:rPr sz="1500">
+                <a:solidFill>
+                  <a:srgbClr val="F5F3EE"/>
+                </a:solidFill>
+                <a:latin typeface="Inter"/>
+              </a:rPr>
+              <a:t>State that interacts — favorites, filter, search &amp; sort all touch each other. Bugs hid in the seams; a review found 11 issues in the sidebar alone (an async race, keyboard focus traps).</a:t>
+            </a:r>
+          </a:p>
+        </p:txBody>
+      </p:sp>
+      <p:sp>
+        <p:nvSpPr>
+          <p:cNvPr id="7" name="Rounded Rectangle 6"/>
+          <p:cNvSpPr/>
+          <p:nvPr/>
+        </p:nvSpPr>
+        <p:spPr>
+          <a:xfrm>
+            <a:off x="8403336" y="1828800"/>
+            <a:ext cx="3520440" cy="4206240"/>
+          </a:xfrm>
+          <a:prstGeom prst="roundRect">
+            <a:avLst>
+              <a:gd name="adj" fmla="val 5000"/>
+            </a:avLst>
+          </a:prstGeom>
+          <a:solidFill>
+            <a:srgbClr val="4A422E"/>
+          </a:solidFill>
+          <a:ln>
+            <a:noFill/>
+          </a:ln>
+          <a:effectLst/>
+        </p:spPr>
+        <p:style>
+          <a:lnRef idx="1">
+            <a:schemeClr val="accent1"/>
+          </a:lnRef>
+          <a:fillRef idx="3">
+            <a:schemeClr val="accent1"/>
+          </a:fillRef>
+          <a:effectRef idx="2">
+            <a:schemeClr val="accent1"/>
+          </a:effectRef>
+          <a:fontRef idx="minor">
+            <a:schemeClr val="lt1"/>
+          </a:fontRef>
+        </p:style>
+        <p:txBody>
+          <a:bodyPr rtlCol="0" anchor="t" wrap="square" lIns="256032" rIns="256032" tIns="256032"/>
+          <a:lstStyle/>
+          <a:p>
+            <a:pPr algn="ctr">
+              <a:spcAft>
+                <a:spcPts val="1400"/>
+              </a:spcAft>
+            </a:pPr>
+            <a:r>
+              <a:rPr sz="2000" b="1">
+                <a:solidFill>
+                  <a:srgbClr val="EAE0CF"/>
+                </a:solidFill>
+                <a:latin typeface="Poppins"/>
+              </a:rPr>
+              <a:t>🚀 Next Steps</a:t>
+            </a:r>
+          </a:p>
+          <a:p>
+            <a:pPr>
+              <a:lnSpc>
+                <a:spcPct val="118000"/>
+              </a:lnSpc>
+            </a:pPr>
+            <a:r>
+              <a:rPr sz="1500">
+                <a:solidFill>
+                  <a:srgbClr val="F5F3EE"/>
+                </a:solidFill>
+                <a:latin typeface="Inter"/>
+              </a:rPr>
+              <a:t>Deploy to Render for a live link · persist favorites in localStorage so they survive a reload · add user accounts / saved lists.</a:t>
             </a:r>
           </a:p>
         </p:txBody>

</xml_diff>